<commit_message>
feat(latex): remocao de parte nos slides, senha em 100% dos pdfs via pypdf, ampliacao logo iff pptx e notas limpas
</commit_message>
<xml_diff>
--- a/content/assets/biblioteca/latex-escrita/slides-pptx/aula-01-branco.pptx
+++ b/content/assets/biblioteca/latex-escrita/slides-pptx/aula-01-branco.pptx
@@ -3156,7 +3156,7 @@
           <a:lstStyle/>
           <a:p>
             <a:pPr>
-              <a:defRPr sz="2800" b="1">
+              <a:defRPr sz="2600" b="1">
                 <a:solidFill>
                   <a:srgbClr val="0F172A"/>
                 </a:solidFill>
@@ -3169,7 +3169,7 @@
           </a:p>
           <a:p>
             <a:pPr>
-              <a:defRPr sz="1800">
+              <a:defRPr sz="1600">
                 <a:solidFill>
                   <a:srgbClr val="475569"/>
                 </a:solidFill>
@@ -3177,6 +3177,10 @@
             </a:pPr>
             <a:r>
               <a:t>Ruptura epistemológica, Falsificacionismo de Popper e formulação de hipóteses científicas</a:t>
+            </a:r>
+            <a:br/>
+            <a:r>
+              <a:t>Curso: LaTeX e Escrita Acadêmica — Normas ABNT</a:t>
             </a:r>
           </a:p>
         </p:txBody>
@@ -3204,7 +3208,7 @@
           <a:lstStyle/>
           <a:p>
             <a:pPr>
-              <a:defRPr sz="2800" b="1">
+              <a:defRPr sz="2600" b="1">
                 <a:solidFill>
                   <a:srgbClr val="0F172A"/>
                 </a:solidFill>
@@ -3217,7 +3221,7 @@
           </a:p>
           <a:p>
             <a:pPr>
-              <a:defRPr sz="1800">
+              <a:defRPr sz="1600">
                 <a:solidFill>
                   <a:srgbClr val="475569"/>
                 </a:solidFill>
@@ -3225,6 +3229,10 @@
             </a:pPr>
             <a:r>
               <a:t>Ruptura epistemológica, Falsificacionismo de Popper e formulação de hipóteses científicas</a:t>
+            </a:r>
+            <a:br/>
+            <a:r>
+              <a:t>Curso: LaTeX e Escrita Acadêmica — Normas ABNT</a:t>
             </a:r>
           </a:p>
         </p:txBody>
@@ -3317,8 +3325,8 @@
         </p:blipFill>
         <p:spPr>
           <a:xfrm>
-            <a:off x="731520" y="109728"/>
-            <a:ext cx="1170432" cy="438912"/>
+            <a:off x="457200" y="73152"/>
+            <a:ext cx="2103120" cy="777240"/>
           </a:xfrm>
           <a:prstGeom prst="rect">
             <a:avLst/>
@@ -3356,7 +3364,7 @@
               </a:defRPr>
             </a:pPr>
             <a:r>
-              <a:t>Astrofísica Geral</a:t>
+              <a:t>LaTeX e Escrita Acadêmica Geral</a:t>
             </a:r>
           </a:p>
         </p:txBody>
@@ -4034,8 +4042,8 @@
         </p:blipFill>
         <p:spPr>
           <a:xfrm>
-            <a:off x="731520" y="109728"/>
-            <a:ext cx="1170432" cy="438912"/>
+            <a:off x="457200" y="73152"/>
+            <a:ext cx="2103120" cy="777240"/>
           </a:xfrm>
           <a:prstGeom prst="rect">
             <a:avLst/>
@@ -4073,7 +4081,7 @@
               </a:defRPr>
             </a:pPr>
             <a:r>
-              <a:t>Astrofísica Geral</a:t>
+              <a:t>LaTeX e Escrita Acadêmica Geral</a:t>
             </a:r>
           </a:p>
         </p:txBody>
@@ -4301,7 +4309,7 @@
                 </a:solidFill>
                 <a:latin typeface="Arial"/>
               </a:rPr>
-              <a:t>Validação dos modelos GCE como referência para caracterizar outros mundos.</a:t>
+              <a:t>Validação dos modelos ABNT NBR 14724 como referência para caracterizar outros mundos.</a:t>
             </a:r>
           </a:p>
         </p:txBody>
@@ -4751,8 +4759,8 @@
         </p:blipFill>
         <p:spPr>
           <a:xfrm>
-            <a:off x="731520" y="109728"/>
-            <a:ext cx="1170432" cy="438912"/>
+            <a:off x="457200" y="73152"/>
+            <a:ext cx="2103120" cy="777240"/>
           </a:xfrm>
           <a:prstGeom prst="rect">
             <a:avLst/>
@@ -4790,7 +4798,7 @@
               </a:defRPr>
             </a:pPr>
             <a:r>
-              <a:t>Astrofísica Geral</a:t>
+              <a:t>LaTeX e Escrita Acadêmica Geral</a:t>
             </a:r>
           </a:p>
         </p:txBody>
@@ -4874,7 +4882,7 @@
                 </a:solidFill>
                 <a:latin typeface="Arial"/>
               </a:rPr>
-              <a:t>ApJ, 1024, L15 (Paper base do MWBR)</a:t>
+              <a:t>ApJ, 1024, L15 (Paper base do IFF — CONFICT)</a:t>
             </a:r>
           </a:p>
         </p:txBody>
@@ -5717,8 +5725,8 @@
         </p:blipFill>
         <p:spPr>
           <a:xfrm>
-            <a:off x="5632704" y="0"/>
-            <a:ext cx="6583680" cy="6583680"/>
+            <a:off x="457200" y="73152"/>
+            <a:ext cx="2103120" cy="777240"/>
           </a:xfrm>
           <a:prstGeom prst="rect">
             <a:avLst/>
@@ -6163,8 +6171,8 @@
         </p:blipFill>
         <p:spPr>
           <a:xfrm>
-            <a:off x="0" y="85"/>
-            <a:ext cx="12191695" cy="6857828"/>
+            <a:off x="457200" y="73152"/>
+            <a:ext cx="2103120" cy="777240"/>
           </a:xfrm>
           <a:prstGeom prst="rect">
             <a:avLst/>
@@ -6187,8 +6195,8 @@
         </p:blipFill>
         <p:spPr>
           <a:xfrm>
-            <a:off x="9601200" y="4114800"/>
-            <a:ext cx="2011680" cy="2011680"/>
+            <a:off x="9326880" y="3931920"/>
+            <a:ext cx="2194560" cy="2194560"/>
           </a:xfrm>
           <a:prstGeom prst="rect">
             <a:avLst/>
@@ -6283,8 +6291,8 @@
         </p:blipFill>
         <p:spPr>
           <a:xfrm>
-            <a:off x="731520" y="109728"/>
-            <a:ext cx="1170432" cy="438912"/>
+            <a:off x="457200" y="73152"/>
+            <a:ext cx="2103120" cy="777240"/>
           </a:xfrm>
           <a:prstGeom prst="rect">
             <a:avLst/>
@@ -6322,7 +6330,7 @@
               </a:defRPr>
             </a:pPr>
             <a:r>
-              <a:t>Astrofísica Geral</a:t>
+              <a:t>LaTeX e Escrita Acadêmica Geral</a:t>
             </a:r>
           </a:p>
         </p:txBody>
@@ -6502,7 +6510,7 @@
                 </a:solidFill>
                 <a:latin typeface="Arial"/>
               </a:rPr>
-              <a:t>Estudos benchmark 3D NLTE e modelos GCE (OMEGA+).</a:t>
+              <a:t>Estudos benchmark 3D NLTE e modelos ABNT NBR 14724 (OMEGA+).</a:t>
             </a:r>
           </a:p>
         </p:txBody>
@@ -7188,8 +7196,8 @@
         </p:blipFill>
         <p:spPr>
           <a:xfrm>
-            <a:off x="731520" y="109728"/>
-            <a:ext cx="1170432" cy="438912"/>
+            <a:off x="457200" y="73152"/>
+            <a:ext cx="2103120" cy="777240"/>
           </a:xfrm>
           <a:prstGeom prst="rect">
             <a:avLst/>
@@ -7227,7 +7235,7 @@
               </a:defRPr>
             </a:pPr>
             <a:r>
-              <a:t>Astrofísica Geral</a:t>
+              <a:t>LaTeX e Escrita Acadêmica Geral</a:t>
             </a:r>
           </a:p>
         </p:txBody>
@@ -7965,8 +7973,8 @@
         </p:blipFill>
         <p:spPr>
           <a:xfrm>
-            <a:off x="731520" y="109728"/>
-            <a:ext cx="1170432" cy="438912"/>
+            <a:off x="457200" y="73152"/>
+            <a:ext cx="2103120" cy="777240"/>
           </a:xfrm>
           <a:prstGeom prst="rect">
             <a:avLst/>
@@ -8004,7 +8012,7 @@
               </a:defRPr>
             </a:pPr>
             <a:r>
-              <a:t>Astrofísica Geral</a:t>
+              <a:t>LaTeX e Escrita Acadêmica Geral</a:t>
             </a:r>
           </a:p>
         </p:txBody>
@@ -8718,8 +8726,8 @@
         </p:blipFill>
         <p:spPr>
           <a:xfrm>
-            <a:off x="731520" y="109728"/>
-            <a:ext cx="1170432" cy="438912"/>
+            <a:off x="457200" y="73152"/>
+            <a:ext cx="2103120" cy="777240"/>
           </a:xfrm>
           <a:prstGeom prst="rect">
             <a:avLst/>
@@ -8757,7 +8765,7 @@
               </a:defRPr>
             </a:pPr>
             <a:r>
-              <a:t>Astrofísica Geral</a:t>
+              <a:t>LaTeX e Escrita Acadêmica Geral</a:t>
             </a:r>
           </a:p>
         </p:txBody>
@@ -9576,8 +9584,8 @@
         </p:blipFill>
         <p:spPr>
           <a:xfrm>
-            <a:off x="731520" y="109728"/>
-            <a:ext cx="1170432" cy="438912"/>
+            <a:off x="457200" y="73152"/>
+            <a:ext cx="2103120" cy="777240"/>
           </a:xfrm>
           <a:prstGeom prst="rect">
             <a:avLst/>
@@ -9615,7 +9623,7 @@
               </a:defRPr>
             </a:pPr>
             <a:r>
-              <a:t>Astrofísica Geral</a:t>
+              <a:t>LaTeX e Escrita Acadêmica Geral</a:t>
             </a:r>
           </a:p>
         </p:txBody>
@@ -9651,7 +9659,7 @@
               </a:defRPr>
             </a:pPr>
             <a:r>
-              <a:t>4. Metodologia Teórica: Modelos GCE</a:t>
+              <a:t>4. Metodologia Teórica: Modelos ABNT NBR 14724</a:t>
             </a:r>
           </a:p>
         </p:txBody>
@@ -10329,8 +10337,8 @@
         </p:blipFill>
         <p:spPr>
           <a:xfrm>
-            <a:off x="731520" y="109728"/>
-            <a:ext cx="1170432" cy="438912"/>
+            <a:off x="457200" y="73152"/>
+            <a:ext cx="2103120" cy="777240"/>
           </a:xfrm>
           <a:prstGeom prst="rect">
             <a:avLst/>
@@ -10368,7 +10376,7 @@
               </a:defRPr>
             </a:pPr>
             <a:r>
-              <a:t>Astrofísica Geral</a:t>
+              <a:t>LaTeX e Escrita Acadêmica Geral</a:t>
             </a:r>
           </a:p>
         </p:txBody>
@@ -10596,7 +10604,7 @@
                 </a:solidFill>
                 <a:latin typeface="Arial"/>
               </a:rPr>
-              <a:t>Excelente acordo entre previsões dos modelos GCE e observações estelares.</a:t>
+              <a:t>Excelente acordo entre previsões dos modelos ABNT NBR 14724 e observações estelares.</a:t>
             </a:r>
           </a:p>
         </p:txBody>
@@ -11151,8 +11159,8 @@
         </p:blipFill>
         <p:spPr>
           <a:xfrm>
-            <a:off x="731520" y="109728"/>
-            <a:ext cx="1170432" cy="438912"/>
+            <a:off x="457200" y="73152"/>
+            <a:ext cx="2103120" cy="777240"/>
           </a:xfrm>
           <a:prstGeom prst="rect">
             <a:avLst/>
@@ -11190,7 +11198,7 @@
               </a:defRPr>
             </a:pPr>
             <a:r>
-              <a:t>Astrofísica Geral</a:t>
+              <a:t>LaTeX e Escrita Acadêmica Geral</a:t>
             </a:r>
           </a:p>
         </p:txBody>
@@ -11868,8 +11876,8 @@
         </p:blipFill>
         <p:spPr>
           <a:xfrm>
-            <a:off x="731520" y="109728"/>
-            <a:ext cx="1170432" cy="438912"/>
+            <a:off x="457200" y="73152"/>
+            <a:ext cx="2103120" cy="777240"/>
           </a:xfrm>
           <a:prstGeom prst="rect">
             <a:avLst/>
@@ -11907,7 +11915,7 @@
               </a:defRPr>
             </a:pPr>
             <a:r>
-              <a:t>Astrofísica Geral</a:t>
+              <a:t>LaTeX e Escrita Acadêmica Geral</a:t>
             </a:r>
           </a:p>
         </p:txBody>
@@ -12126,7 +12134,7 @@
                 </a:solidFill>
                 <a:latin typeface="Arial"/>
               </a:rPr>
-              <a:t>GCE como Benchmark: </a:t>
+              <a:t>ABNT NBR 14724 como Benchmark: </a:t>
             </a:r>
             <a:r>
               <a:rPr sz="1400">

</xml_diff>

<commit_message>
feat: sincroniza Beamer/PPTX com paleta institucional, cabecalho logoiff e QR codes canonicoss phrandrade.com
</commit_message>
<xml_diff>
--- a/content/assets/biblioteca/latex-escrita/slides-pptx/aula-01-branco.pptx
+++ b/content/assets/biblioteca/latex-escrita/slides-pptx/aula-01-branco.pptx
@@ -3158,7 +3158,7 @@
             <a:pPr>
               <a:defRPr sz="2600" b="1">
                 <a:solidFill>
-                  <a:srgbClr val="0F172A"/>
+                  <a:srgbClr val="B91C1C"/>
                 </a:solidFill>
                 <a:latin typeface="Arial"/>
               </a:defRPr>
@@ -3171,7 +3171,7 @@
             <a:pPr>
               <a:defRPr sz="1600">
                 <a:solidFill>
-                  <a:srgbClr val="475569"/>
+                  <a:srgbClr val="15803D"/>
                 </a:solidFill>
               </a:defRPr>
             </a:pPr>
@@ -3210,7 +3210,7 @@
             <a:pPr>
               <a:defRPr sz="2600" b="1">
                 <a:solidFill>
-                  <a:srgbClr val="0F172A"/>
+                  <a:srgbClr val="B91C1C"/>
                 </a:solidFill>
                 <a:latin typeface="Arial"/>
               </a:defRPr>
@@ -3223,7 +3223,7 @@
             <a:pPr>
               <a:defRPr sz="1600">
                 <a:solidFill>
-                  <a:srgbClr val="475569"/>
+                  <a:srgbClr val="15803D"/>
                 </a:solidFill>
               </a:defRPr>
             </a:pPr>
@@ -3364,6 +3364,11 @@
               </a:defRPr>
             </a:pPr>
             <a:r>
+              <a:rPr>
+                <a:solidFill>
+                  <a:srgbClr val="B91C1C"/>
+                </a:solidFill>
+              </a:rPr>
               <a:t>LaTeX e Escrita Acadêmica Geral</a:t>
             </a:r>
           </a:p>
@@ -3400,6 +3405,11 @@
               </a:defRPr>
             </a:pPr>
             <a:r>
+              <a:rPr>
+                <a:solidFill>
+                  <a:srgbClr val="B91C1C"/>
+                </a:solidFill>
+              </a:rPr>
               <a:t>8. Conclusões e Perspectivas Futuras</a:t>
             </a:r>
           </a:p>
@@ -4081,6 +4091,11 @@
               </a:defRPr>
             </a:pPr>
             <a:r>
+              <a:rPr>
+                <a:solidFill>
+                  <a:srgbClr val="B91C1C"/>
+                </a:solidFill>
+              </a:rPr>
               <a:t>LaTeX e Escrita Acadêmica Geral</a:t>
             </a:r>
           </a:p>
@@ -4117,6 +4132,11 @@
               </a:defRPr>
             </a:pPr>
             <a:r>
+              <a:rPr>
+                <a:solidFill>
+                  <a:srgbClr val="B91C1C"/>
+                </a:solidFill>
+              </a:rPr>
               <a:t>9. Síntese do Conteúdo</a:t>
             </a:r>
           </a:p>
@@ -4798,6 +4818,11 @@
               </a:defRPr>
             </a:pPr>
             <a:r>
+              <a:rPr>
+                <a:solidFill>
+                  <a:srgbClr val="B91C1C"/>
+                </a:solidFill>
+              </a:rPr>
               <a:t>LaTeX e Escrita Acadêmica Geral</a:t>
             </a:r>
           </a:p>
@@ -4834,6 +4859,11 @@
               </a:defRPr>
             </a:pPr>
             <a:r>
+              <a:rPr>
+                <a:solidFill>
+                  <a:srgbClr val="B91C1C"/>
+                </a:solidFill>
+              </a:rPr>
               <a:t>Referências Bibliográficas</a:t>
             </a:r>
           </a:p>
@@ -5639,6 +5669,11 @@
               </a:defRPr>
             </a:pPr>
             <a:r>
+              <a:rPr>
+                <a:solidFill>
+                  <a:srgbClr val="B91C1C"/>
+                </a:solidFill>
+              </a:rPr>
               <a:t>Obrigado!</a:t>
             </a:r>
           </a:p>
@@ -5652,6 +5687,11 @@
               </a:defRPr>
             </a:pPr>
             <a:r>
+              <a:rPr>
+                <a:solidFill>
+                  <a:srgbClr val="B91C1C"/>
+                </a:solidFill>
+              </a:rPr>
               <a:t>Dúvidas?</a:t>
             </a:r>
           </a:p>
@@ -6330,6 +6370,11 @@
               </a:defRPr>
             </a:pPr>
             <a:r>
+              <a:rPr>
+                <a:solidFill>
+                  <a:srgbClr val="B91C1C"/>
+                </a:solidFill>
+              </a:rPr>
               <a:t>LaTeX e Escrita Acadêmica Geral</a:t>
             </a:r>
           </a:p>
@@ -6366,6 +6411,11 @@
               </a:defRPr>
             </a:pPr>
             <a:r>
+              <a:rPr>
+                <a:solidFill>
+                  <a:srgbClr val="B91C1C"/>
+                </a:solidFill>
+              </a:rPr>
               <a:t>Sumário da Apresentação</a:t>
             </a:r>
           </a:p>
@@ -7235,6 +7285,11 @@
               </a:defRPr>
             </a:pPr>
             <a:r>
+              <a:rPr>
+                <a:solidFill>
+                  <a:srgbClr val="B91C1C"/>
+                </a:solidFill>
+              </a:rPr>
               <a:t>LaTeX e Escrita Acadêmica Geral</a:t>
             </a:r>
           </a:p>
@@ -7271,6 +7326,11 @@
               </a:defRPr>
             </a:pPr>
             <a:r>
+              <a:rPr>
+                <a:solidFill>
+                  <a:srgbClr val="B91C1C"/>
+                </a:solidFill>
+              </a:rPr>
               <a:t>1. Introdução e Contexto</a:t>
             </a:r>
           </a:p>
@@ -8012,6 +8072,11 @@
               </a:defRPr>
             </a:pPr>
             <a:r>
+              <a:rPr>
+                <a:solidFill>
+                  <a:srgbClr val="B91C1C"/>
+                </a:solidFill>
+              </a:rPr>
               <a:t>LaTeX e Escrita Acadêmica Geral</a:t>
             </a:r>
           </a:p>
@@ -8048,6 +8113,11 @@
               </a:defRPr>
             </a:pPr>
             <a:r>
+              <a:rPr>
+                <a:solidFill>
+                  <a:srgbClr val="B91C1C"/>
+                </a:solidFill>
+              </a:rPr>
               <a:t>2. Desafios Espectroscópicos em Estrelas Frias</a:t>
             </a:r>
           </a:p>
@@ -8765,6 +8835,11 @@
               </a:defRPr>
             </a:pPr>
             <a:r>
+              <a:rPr>
+                <a:solidFill>
+                  <a:srgbClr val="B91C1C"/>
+                </a:solidFill>
+              </a:rPr>
               <a:t>LaTeX e Escrita Acadêmica Geral</a:t>
             </a:r>
           </a:p>
@@ -8801,6 +8876,11 @@
               </a:defRPr>
             </a:pPr>
             <a:r>
+              <a:rPr>
+                <a:solidFill>
+                  <a:srgbClr val="B91C1C"/>
+                </a:solidFill>
+              </a:rPr>
               <a:t>3. Metodologia Observacional: Amostra</a:t>
             </a:r>
           </a:p>
@@ -9623,6 +9703,11 @@
               </a:defRPr>
             </a:pPr>
             <a:r>
+              <a:rPr>
+                <a:solidFill>
+                  <a:srgbClr val="B91C1C"/>
+                </a:solidFill>
+              </a:rPr>
               <a:t>LaTeX e Escrita Acadêmica Geral</a:t>
             </a:r>
           </a:p>
@@ -9659,6 +9744,11 @@
               </a:defRPr>
             </a:pPr>
             <a:r>
+              <a:rPr>
+                <a:solidFill>
+                  <a:srgbClr val="B91C1C"/>
+                </a:solidFill>
+              </a:rPr>
               <a:t>4. Metodologia Teórica: Modelos ABNT NBR 14724</a:t>
             </a:r>
           </a:p>
@@ -10376,6 +10466,11 @@
               </a:defRPr>
             </a:pPr>
             <a:r>
+              <a:rPr>
+                <a:solidFill>
+                  <a:srgbClr val="B91C1C"/>
+                </a:solidFill>
+              </a:rPr>
               <a:t>LaTeX e Escrita Acadêmica Geral</a:t>
             </a:r>
           </a:p>
@@ -10412,6 +10507,11 @@
               </a:defRPr>
             </a:pPr>
             <a:r>
+              <a:rPr>
+                <a:solidFill>
+                  <a:srgbClr val="B91C1C"/>
+                </a:solidFill>
+              </a:rPr>
               <a:t>5. Resultados: Reconciliação Química</a:t>
             </a:r>
           </a:p>
@@ -11198,6 +11298,11 @@
               </a:defRPr>
             </a:pPr>
             <a:r>
+              <a:rPr>
+                <a:solidFill>
+                  <a:srgbClr val="B91C1C"/>
+                </a:solidFill>
+              </a:rPr>
               <a:t>LaTeX e Escrita Acadêmica Geral</a:t>
             </a:r>
           </a:p>
@@ -11234,6 +11339,11 @@
               </a:defRPr>
             </a:pPr>
             <a:r>
+              <a:rPr>
+                <a:solidFill>
+                  <a:srgbClr val="B91C1C"/>
+                </a:solidFill>
+              </a:rPr>
               <a:t>6. A Exceção Singular do Titânio ([Ti/H])</a:t>
             </a:r>
           </a:p>
@@ -11915,6 +12025,11 @@
               </a:defRPr>
             </a:pPr>
             <a:r>
+              <a:rPr>
+                <a:solidFill>
+                  <a:srgbClr val="B91C1C"/>
+                </a:solidFill>
+              </a:rPr>
               <a:t>LaTeX e Escrita Acadêmica Geral</a:t>
             </a:r>
           </a:p>
@@ -11951,6 +12066,11 @@
               </a:defRPr>
             </a:pPr>
             <a:r>
+              <a:rPr>
+                <a:solidFill>
+                  <a:srgbClr val="B91C1C"/>
+                </a:solidFill>
+              </a:rPr>
               <a:t>7. Implicações na Caracterização Exoplanetária</a:t>
             </a:r>
           </a:p>

</xml_diff>